<commit_message>
Trabalhos de sala: fazer as três atividades; aluno que entra depois; decks regerados com infográfico da avaliação
</commit_message>
<xml_diff>
--- a/slides/aula-02-stakeholders-objetivos-conflitos.pptx
+++ b/slides/aula-02-stakeholders-objetivos-conflitos.pptx
@@ -957,7 +957,7 @@
           <a:p>
             <a:r>
               <a:rPr lang="en-US" dirty="0"/>
-              <a:t>Correção binária: entregou no prazo e no formato, pontuou.</a:t>
+              <a:t>As três atividades são complementares: a 1 produz, a 2 transforma, a 3 usa e critica IA. Correção binária: entregou as três no prazo e no formato, pontuou.</a:t>
             </a:r>
             <a:endParaRPr lang="en-US" dirty="0"/>
           </a:p>
@@ -2999,9 +2999,9 @@
             <a:tbl>
               <a:tblPr/>
               <a:tblGrid>
-                <a:gridCol w="2286000"/>
-                <a:gridCol w="1005840"/>
-                <a:gridCol w="4937760"/>
+                <a:gridCol w="2194560"/>
+                <a:gridCol w="3017520"/>
+                <a:gridCol w="3017520"/>
               </a:tblGrid>
               <a:tr h="310896">
                 <a:tc>
@@ -4640,7 +4640,7 @@
                 <a:ea typeface="Calibri" pitchFamily="34" charset="-122"/>
                 <a:cs typeface="Calibri" pitchFamily="34" charset="-120"/>
               </a:rPr>
-              <a:t>Em grupo (3 a 5 pessoas) — escolham 1 das 3 opções</a:t>
+              <a:t>Em grupo (3 a 5 pessoas) — as três atividades, na ordem</a:t>
             </a:r>
             <a:endParaRPr lang="en-US" sz="1300" dirty="0"/>
           </a:p>
@@ -5054,7 +5054,7 @@
                 <a:ea typeface="Calibri" pitchFamily="34" charset="-122"/>
                 <a:cs typeface="Calibri" pitchFamily="34" charset="-120"/>
               </a:rPr>
-              <a:t>Entrega ao final do encontro · vale 0,25</a:t>
+              <a:t>As três, entregues ao final do encontro · valem 0,25</a:t>
             </a:r>
             <a:endParaRPr lang="en-US" sz="1000" dirty="0"/>
           </a:p>

</xml_diff>